<commit_message>
Make slide generator configurable
Co-authored-by: mciafe <224478359+mciafe@users.noreply.github.com>
</commit_message>
<xml_diff>
--- a/ver65_ver85_capability_comparison.pptx
+++ b/ver65_ver85_capability_comparison.pptx
@@ -3143,7 +3143,6 @@
                 <a:solidFill>
                   <a:srgbClr val="2A3440"/>
                 </a:solidFill>
-                <a:latin typeface="Yu Gothic"/>
               </a:rPr>
               <a:t>実装追加により、回答できる問の範囲が拡大</a:t>
             </a:r>
@@ -3197,7 +3196,6 @@
                 <a:solidFill>
                   <a:srgbClr val="FFFFFF"/>
                 </a:solidFill>
-                <a:latin typeface="Yu Gothic"/>
               </a:rPr>
               <a:t>ver65</a:t>
             </a:r>
@@ -3251,7 +3249,6 @@
                 <a:solidFill>
                   <a:srgbClr val="FFFFFF"/>
                 </a:solidFill>
-                <a:latin typeface="Yu Gothic"/>
               </a:rPr>
               <a:t>追加実装</a:t>
             </a:r>
@@ -3305,7 +3302,6 @@
                 <a:solidFill>
                   <a:srgbClr val="FFFFFF"/>
                 </a:solidFill>
-                <a:latin typeface="Yu Gothic"/>
               </a:rPr>
               <a:t>ver85</a:t>
             </a:r>
@@ -3359,7 +3355,6 @@
                 <a:solidFill>
                   <a:srgbClr val="2A3440"/>
                 </a:solidFill>
-                <a:latin typeface="Yu Gothic"/>
               </a:rPr>
               <a:t/>
             </a:r>
@@ -3413,7 +3408,6 @@
                 <a:solidFill>
                   <a:srgbClr val="2A3440"/>
                 </a:solidFill>
-                <a:latin typeface="Yu Gothic"/>
               </a:rPr>
               <a:t/>
             </a:r>
@@ -3467,7 +3461,6 @@
                 <a:solidFill>
                   <a:srgbClr val="2A3440"/>
                 </a:solidFill>
-                <a:latin typeface="Yu Gothic"/>
               </a:rPr>
               <a:t>回答できる問の範囲</a:t>
             </a:r>
@@ -3521,7 +3514,6 @@
                 <a:solidFill>
                   <a:srgbClr val="2A3440"/>
                 </a:solidFill>
-                <a:latin typeface="Yu Gothic"/>
               </a:rPr>
               <a:t>回答できる問の範囲</a:t>
             </a:r>
@@ -3575,7 +3567,6 @@
                 <a:solidFill>
                   <a:srgbClr val="808A96"/>
                 </a:solidFill>
-                <a:latin typeface="Yu Gothic"/>
               </a:rPr>
               <a:t>ユーザの問集合</a:t>
             </a:r>
@@ -3629,7 +3620,6 @@
                 <a:solidFill>
                   <a:srgbClr val="808A96"/>
                 </a:solidFill>
-                <a:latin typeface="Yu Gothic"/>
               </a:rPr>
               <a:t>ユーザの問集合</a:t>
             </a:r>
@@ -3683,7 +3673,6 @@
                 <a:solidFill>
                   <a:srgbClr val="FFFFFF"/>
                 </a:solidFill>
-                <a:latin typeface="Yu Gothic"/>
               </a:rPr>
               <a:t>ver65
 回答可能</a:t>
@@ -3738,7 +3727,6 @@
                 <a:solidFill>
                   <a:srgbClr val="FFFFFF"/>
                 </a:solidFill>
-                <a:latin typeface="Yu Gothic"/>
               </a:rPr>
               <a:t>ver85
 回答可能</a:t>
@@ -3793,7 +3781,6 @@
                 <a:solidFill>
                   <a:srgbClr val="FFFFFF"/>
                 </a:solidFill>
-                <a:latin typeface="Yu Gothic"/>
               </a:rPr>
               <a:t>追加で
 回答可能</a:t>
@@ -3953,7 +3940,6 @@
                 <a:solidFill>
                   <a:srgbClr val="2A3440"/>
                 </a:solidFill>
-                <a:latin typeface="Yu Gothic"/>
               </a:rPr>
               <a:t>一問</a:t>
             </a:r>
@@ -4007,7 +3993,6 @@
                 <a:solidFill>
                   <a:srgbClr val="2A3440"/>
                 </a:solidFill>
-                <a:latin typeface="Yu Gothic"/>
               </a:rPr>
               <a:t>索引あり</a:t>
             </a:r>
@@ -4061,7 +4046,6 @@
                 <a:solidFill>
                   <a:srgbClr val="2A3440"/>
                 </a:solidFill>
-                <a:latin typeface="Yu Gothic"/>
               </a:rPr>
               <a:t>キーワード
 一致</a:t>
@@ -4116,7 +4100,6 @@
                 <a:solidFill>
                   <a:srgbClr val="2A3440"/>
                 </a:solidFill>
-                <a:latin typeface="Yu Gothic"/>
               </a:rPr>
               <a:t>索引なし→不明</a:t>
             </a:r>
@@ -4170,7 +4153,6 @@
                 <a:solidFill>
                   <a:srgbClr val="2A3440"/>
                 </a:solidFill>
-                <a:latin typeface="Yu Gothic"/>
               </a:rPr>
               <a:t>分解できる複数問い</a:t>
             </a:r>
@@ -4224,7 +4206,6 @@
                 <a:solidFill>
                   <a:srgbClr val="2A3440"/>
                 </a:solidFill>
-                <a:latin typeface="Yu Gothic"/>
               </a:rPr>
               <a:t>一問</a:t>
             </a:r>
@@ -4278,7 +4259,6 @@
                 <a:solidFill>
                   <a:srgbClr val="2A3440"/>
                 </a:solidFill>
-                <a:latin typeface="Yu Gothic"/>
               </a:rPr>
               <a:t>索引あり</a:t>
             </a:r>
@@ -4332,7 +4312,6 @@
                 <a:solidFill>
                   <a:srgbClr val="2A3440"/>
                 </a:solidFill>
-                <a:latin typeface="Yu Gothic"/>
               </a:rPr>
               <a:t>類義語理解</a:t>
             </a:r>
@@ -4386,7 +4365,6 @@
                 <a:solidFill>
                   <a:srgbClr val="2A3440"/>
                 </a:solidFill>
-                <a:latin typeface="Yu Gothic"/>
               </a:rPr>
               <a:t>補足情報付与</a:t>
             </a:r>
@@ -4440,7 +4418,6 @@
                 <a:solidFill>
                   <a:srgbClr val="2A3440"/>
                 </a:solidFill>
-                <a:latin typeface="Yu Gothic"/>
               </a:rPr>
               <a:t>ver65の範囲も継承</a:t>
             </a:r>
@@ -4494,7 +4471,6 @@
                 <a:solidFill>
                   <a:srgbClr val="808A96"/>
                 </a:solidFill>
-                <a:latin typeface="Yu Gothic"/>
               </a:rPr>
               <a:t>類義語理解が必要</a:t>
             </a:r>
@@ -4548,7 +4524,6 @@
                 <a:solidFill>
                   <a:srgbClr val="808A96"/>
                 </a:solidFill>
-                <a:latin typeface="Yu Gothic"/>
               </a:rPr>
               <a:t>補足情報付与が必要</a:t>
             </a:r>
@@ -4602,7 +4577,6 @@
                 <a:solidFill>
                   <a:srgbClr val="808A96"/>
                 </a:solidFill>
-                <a:latin typeface="Yu Gothic"/>
               </a:rPr>
               <a:t>分類・分解が困難</a:t>
             </a:r>
@@ -4656,7 +4630,6 @@
                 <a:solidFill>
                   <a:srgbClr val="808A96"/>
                 </a:solidFill>
-                <a:latin typeface="Yu Gothic"/>
               </a:rPr>
               <a:t>ユースケース実現</a:t>
             </a:r>
@@ -4710,7 +4683,6 @@
                 <a:solidFill>
                   <a:srgbClr val="808A96"/>
                 </a:solidFill>
-                <a:latin typeface="Yu Gothic"/>
               </a:rPr>
               <a:t>不具合</a:t>
             </a:r>
@@ -4764,7 +4736,6 @@
                 <a:solidFill>
                   <a:srgbClr val="808A96"/>
                 </a:solidFill>
-                <a:latin typeface="Yu Gothic"/>
               </a:rPr>
               <a:t>入力可能性が低い問</a:t>
             </a:r>
@@ -4818,7 +4789,6 @@
                 <a:solidFill>
                   <a:srgbClr val="808A96"/>
                 </a:solidFill>
-                <a:latin typeface="Yu Gothic"/>
               </a:rPr>
               <a:t>事前知識が必要な
 複数問い</a:t>
@@ -4873,7 +4843,6 @@
                 <a:solidFill>
                   <a:srgbClr val="2A3440"/>
                 </a:solidFill>
-                <a:latin typeface="Yu Gothic"/>
               </a:rPr>
               <a:t>実装</a:t>
             </a:r>
@@ -4927,7 +4896,6 @@
                 <a:solidFill>
                   <a:srgbClr val="2A3440"/>
                 </a:solidFill>
-                <a:latin typeface="Yu Gothic"/>
               </a:rPr>
               <a:t>追加した実装</a:t>
             </a:r>
@@ -4981,7 +4949,6 @@
                 <a:solidFill>
                   <a:srgbClr val="FFFFFF"/>
                 </a:solidFill>
-                <a:latin typeface="Yu Gothic"/>
               </a:rPr>
               <a:t>前処理</a:t>
             </a:r>
@@ -5035,7 +5002,6 @@
                 <a:solidFill>
                   <a:srgbClr val="FFFFFF"/>
                 </a:solidFill>
-                <a:latin typeface="Yu Gothic"/>
               </a:rPr>
               <a:t/>
             </a:r>
@@ -5089,7 +5055,6 @@
                 <a:solidFill>
                   <a:srgbClr val="FFFFFF"/>
                 </a:solidFill>
-                <a:latin typeface="Yu Gothic"/>
               </a:rPr>
               <a:t>RAG検索</a:t>
             </a:r>
@@ -5143,7 +5108,6 @@
                 <a:solidFill>
                   <a:srgbClr val="FFFFFF"/>
                 </a:solidFill>
-                <a:latin typeface="Yu Gothic"/>
               </a:rPr>
               <a:t/>
             </a:r>
@@ -5197,7 +5161,6 @@
                 <a:solidFill>
                   <a:srgbClr val="FFFFFF"/>
                 </a:solidFill>
-                <a:latin typeface="Yu Gothic"/>
               </a:rPr>
               <a:t>回答生成</a:t>
             </a:r>
@@ -5251,7 +5214,6 @@
                 <a:solidFill>
                   <a:srgbClr val="FFFFFF"/>
                 </a:solidFill>
-                <a:latin typeface="Yu Gothic"/>
               </a:rPr>
               <a:t/>
             </a:r>
@@ -5305,7 +5267,6 @@
                 <a:solidFill>
                   <a:srgbClr val="FFFFFF"/>
                 </a:solidFill>
-                <a:latin typeface="Yu Gothic"/>
               </a:rPr>
               <a:t>FAQ出力</a:t>
             </a:r>
@@ -5359,7 +5320,6 @@
                 <a:solidFill>
                   <a:srgbClr val="FFFFFF"/>
                 </a:solidFill>
-                <a:latin typeface="Yu Gothic"/>
               </a:rPr>
               <a:t>前処理</a:t>
             </a:r>
@@ -5413,7 +5373,6 @@
                 <a:solidFill>
                   <a:srgbClr val="FFFFFF"/>
                 </a:solidFill>
-                <a:latin typeface="Yu Gothic"/>
               </a:rPr>
               <a:t/>
             </a:r>
@@ -5467,7 +5426,6 @@
                 <a:solidFill>
                   <a:srgbClr val="FFFFFF"/>
                 </a:solidFill>
-                <a:latin typeface="Yu Gothic"/>
               </a:rPr>
               <a:t>RAG検索</a:t>
             </a:r>
@@ -5521,7 +5479,6 @@
                 <a:solidFill>
                   <a:srgbClr val="FFFFFF"/>
                 </a:solidFill>
-                <a:latin typeface="Yu Gothic"/>
               </a:rPr>
               <a:t/>
             </a:r>
@@ -5575,7 +5532,6 @@
                 <a:solidFill>
                   <a:srgbClr val="FFFFFF"/>
                 </a:solidFill>
-                <a:latin typeface="Yu Gothic"/>
               </a:rPr>
               <a:t>回答生成</a:t>
             </a:r>
@@ -5629,7 +5585,6 @@
                 <a:solidFill>
                   <a:srgbClr val="FFFFFF"/>
                 </a:solidFill>
-                <a:latin typeface="Yu Gothic"/>
               </a:rPr>
               <a:t/>
             </a:r>
@@ -5683,7 +5638,6 @@
                 <a:solidFill>
                   <a:srgbClr val="FFFFFF"/>
                 </a:solidFill>
-                <a:latin typeface="Yu Gothic"/>
               </a:rPr>
               <a:t>FAQ出力</a:t>
             </a:r>
@@ -5737,7 +5691,6 @@
                 <a:solidFill>
                   <a:srgbClr val="FFFFFF"/>
                 </a:solidFill>
-                <a:latin typeface="Yu Gothic"/>
               </a:rPr>
               <a:t>正規化</a:t>
             </a:r>
@@ -5791,7 +5744,6 @@
                 <a:solidFill>
                   <a:srgbClr val="FFFFFF"/>
                 </a:solidFill>
-                <a:latin typeface="Yu Gothic"/>
               </a:rPr>
               <a:t>会話変数定義</a:t>
             </a:r>
@@ -5845,7 +5797,6 @@
                 <a:solidFill>
                   <a:srgbClr val="FFFFFF"/>
                 </a:solidFill>
-                <a:latin typeface="Yu Gothic"/>
               </a:rPr>
               <a:t>レコメンド生成</a:t>
             </a:r>
@@ -6004,7 +5955,6 @@
                 <a:solidFill>
                   <a:srgbClr val="808A96"/>
                 </a:solidFill>
-                <a:latin typeface="Yu Gothic"/>
               </a:rPr>
               <a:t>未対応の領域：ユースケース実現 / 不具合 / 想定外入力 / 分類・分解が難しい複数問い</a:t>
             </a:r>

</xml_diff>